<commit_message>
docs(TV3): refine bug evidence slides with objective observations, CLI execution captures, and preview renders
</commit_message>
<xml_diff>
--- a/docs/slides/TV3_BUG_EVIDENCE_303.pptx
+++ b/docs/slides/TV3_BUG_EVIDENCE_303.pptx
@@ -513,22 +513,22 @@
           </a:p>
           <a:p>
             <a:r>
-              <a:t>- Bằng chứng gốc: docs/evidence/TV3_BUG01_correspondents_500.png và docs/evidence/TV3_BUG01_document_types_500.png.</a:t>
-            </a:r>
-          </a:p>
-          <a:p>
-            <a:r>
-              <a:t>- Phiên bản đã xác minh: Paperless-ngx v3.1.3 (Docker Desktop 29.7.2, Windows 11).</a:t>
-            </a:r>
-          </a:p>
-          <a:p>
-            <a:r>
-              <a:t>- Chi tiết tái hiện: Lỗi do TV2 phát hiện đầu tiên trên Tag. TV3 đã tái hiện độc lập 100% trên Correspondents và Document Types bằng 2 lượt gọi HTTP thực tế.</a:t>
-            </a:r>
-          </a:p>
-          <a:p>
-            <a:r>
-              <a:t>- Điểm lưu ý trả lời giảng viên: Không tự suy đoán lỗi do TypeError hay ép kiểu ORM nếu chưa trích xuất traceback từ log container; ghi nhận chuẩn xác là Unhandled Server Error ở lớp PermissionsMixin dùng chung.</a:t>
+              <a:t>- Bằng chứng thực thi: docs/evidence/TV3_BUG01_correspondents_500.png và docs/evidence/TV3_BUG01_document_types_500.png.</a:t>
+            </a:r>
+          </a:p>
+          <a:p>
+            <a:r>
+              <a:t>- Quan sát cốt lõi: Gửi set_permissions.view dạng boolean dẫn đến HTTP 500 trên cả hai endpoint /api/correspondents/ và /api/document_types/. Hệ thống cần từ chối đầu vào sai kiểu bằng phản hồi 4xx phù hợp (kỳ vọng cụ thể: HTTP 400 Bad Request).</a:t>
+            </a:r>
+          </a:p>
+          <a:p>
+            <a:r>
+              <a:t>- Đánh giá mức độ nghiêm trọng: Severity đề xuất là High (để nhóm thảo luận và thống nhất), vì máy chủ phát sinh lỗi 500 đối với payload sai định dạng dữ liệu thay vì trả mã 4xx từ chối an toàn.</a:t>
+            </a:r>
+          </a:p>
+          <a:p>
+            <a:r>
+              <a:t>- Điểm lưu ý bảo vệ đồ án: Giữ đúng nguyên tắc kiểm thử hộp đen; không quy kết nguyên nhân do lỗi serializer, TypeError hay ORM nếu chưa trích xuất traceback từ container logs.</a:t>
             </a:r>
           </a:p>
         </p:txBody>
@@ -608,22 +608,27 @@
           </a:p>
           <a:p>
             <a:r>
-              <a:t>- Bằng chứng gốc: docs/evidence/TV3_BUG03_response_201.png, docs/evidence/TV3_BUG03_schema_required.png, docs/openapi_TV3.json.</a:t>
-            </a:r>
-          </a:p>
-          <a:p>
-            <a:r>
-              <a:t>- Mã băm schema SHA256: 888b0f89ec0a9f65293f5320a86b1810d7904f93033178b567e313d951b12e3a.</a:t>
-            </a:r>
-          </a:p>
-          <a:p>
-            <a:r>
-              <a:t>- Chi tiết tái hiện: Đã xác thực qua 2 lần POST tạo mới ID 111 và ID 112 trên instance local. Cả 2 lần response 201 đều chỉ có 8 trường và thiếu 3 trường required.</a:t>
-            </a:r>
-          </a:p>
-          <a:p>
-            <a:r>
-              <a:t>- Điểm lưu ý trả lời giảng viên: Phân tích rõ nguyên nhân bất đồng bộ do drf-spectacular dùng chung một schema Correspondent cho cả GET/POST, trong khi trường permissions cần cờ full_perms và 2 trường count/date là thuộc tính annotate chỉ tính toán khi truy vấn danh sách.</a:t>
+              <a:t>- Bằng chứng thực thi: docs/evidence/TV3_BUG03_response_201.png và đối chiếu hợp đồng tại docs/evidence/TV3_BUG03_schema_required.png (trích xuất từ docs/openapi_TV3.json, SHA256: 888b0f89...).</a:t>
+            </a:r>
+          </a:p>
+          <a:p>
+            <a:r>
+              <a:t>- Quan sát cốt lõi: Response 201 của POST /api/correspondents/ thiếu các trường required đã đối chiếu trong OpenAPI, thể hiện sai lệch giữa phản hồi thực tế và hợp đồng API.</a:t>
+            </a:r>
+          </a:p>
+          <a:p>
+            <a:r>
+              <a:t>- Xác minh cụ thể: Cả 3 trường document_count, last_correspondence, permissions đều được schema đánh dấu là required nhưng vắng mặt hoàn toàn trong response 201.</a:t>
+            </a:r>
+          </a:p>
+          <a:p>
+            <a:r>
+              <a:t>- Đánh giá mức độ nghiêm trọng: Severity đề xuất là Medium vì chức năng tạo mới đối tượng trên cơ sở dữ liệu vẫn thành công, nhưng client tự động sinh từ OpenAPI schema có thể bị crash khi parse thiếu trường bắt buộc.</a:t>
+            </a:r>
+          </a:p>
+          <a:p>
+            <a:r>
+              <a:t>- Hướng kiểm tra tiếp theo: Kiểm tra mã nguồn Paperless-ngx 3.1.3 để làm rõ giả thuyết drf-spectacular dùng chung một schema cho cả thao tác đọc và ghi.</a:t>
             </a:r>
           </a:p>
         </p:txBody>
@@ -3625,7 +3630,7 @@
     <p:bg>
       <p:bgPr>
         <a:solidFill>
-          <a:srgbClr val="181825"/>
+          <a:srgbClr val="0C0C0C"/>
         </a:solidFill>
         <a:effectLst/>
       </p:bgPr>
@@ -3645,8 +3650,8 @@
         </p:nvSpPr>
         <p:spPr>
           <a:xfrm>
-            <a:off x="548640" y="320040"/>
-            <a:ext cx="8686800" cy="731520"/>
+            <a:off x="548640" y="292608"/>
+            <a:ext cx="8503920" cy="777240"/>
           </a:xfrm>
           <a:prstGeom prst="rect">
             <a:avLst/>
@@ -3660,9 +3665,9 @@
           <a:lstStyle/>
           <a:p>
             <a:pPr>
-              <a:defRPr sz="2200" b="1">
+              <a:defRPr sz="1900" b="1">
                 <a:solidFill>
-                  <a:srgbClr val="CDD6F4"/>
+                  <a:srgbClr val="E6E6E6"/>
                 </a:solidFill>
               </a:defRPr>
             </a:pPr>
@@ -3672,9 +3677,9 @@
           </a:p>
           <a:p>
             <a:pPr>
-              <a:defRPr sz="1200">
+              <a:defRPr sz="1150">
                 <a:solidFill>
-                  <a:srgbClr val="A6ADC8"/>
+                  <a:srgbClr val="969696"/>
                 </a:solidFill>
               </a:defRPr>
             </a:pPr>
@@ -3692,18 +3697,18 @@
         </p:nvSpPr>
         <p:spPr>
           <a:xfrm>
-            <a:off x="9601200" y="365760"/>
-            <a:ext cx="2011680" cy="411480"/>
+            <a:off x="9144000" y="365760"/>
+            <a:ext cx="2468880" cy="411480"/>
           </a:xfrm>
           <a:prstGeom prst="roundRect">
             <a:avLst/>
           </a:prstGeom>
           <a:solidFill>
-            <a:srgbClr val="F38BA8"/>
+            <a:srgbClr val="E06C75"/>
           </a:solidFill>
           <a:ln>
             <a:solidFill>
-              <a:srgbClr val="F38BA8"/>
+              <a:srgbClr val="E06C75"/>
             </a:solidFill>
           </a:ln>
         </p:spPr>
@@ -3726,14 +3731,14 @@
           <a:lstStyle/>
           <a:p>
             <a:pPr algn="ctr">
-              <a:defRPr sz="1200" b="1">
+              <a:defRPr sz="1100" b="1">
                 <a:solidFill>
-                  <a:srgbClr val="11111B"/>
+                  <a:srgbClr val="000000"/>
                 </a:solidFill>
               </a:defRPr>
             </a:pPr>
             <a:r>
-              <a:t>ĐÃ TÁI HIỆN (HIGH)</a:t>
+              <a:t>Severity đề xuất: High</a:t>
             </a:r>
           </a:p>
         </p:txBody>
@@ -3801,11 +3806,11 @@
             <a:avLst/>
           </a:prstGeom>
           <a:solidFill>
-            <a:srgbClr val="1E1E2E"/>
+            <a:srgbClr val="181818"/>
           </a:solidFill>
           <a:ln w="12700">
             <a:solidFill>
-              <a:srgbClr val="45475A"/>
+              <a:srgbClr val="333333"/>
             </a:solidFill>
           </a:ln>
         </p:spPr>
@@ -3830,12 +3835,12 @@
             <a:pPr algn="ctr">
               <a:defRPr sz="1300" b="1">
                 <a:solidFill>
-                  <a:srgbClr val="F9E2AF"/>
+                  <a:srgbClr val="E5C07B"/>
                 </a:solidFill>
               </a:defRPr>
             </a:pPr>
             <a:r>
-              <a:t>TÓM TẮT KỸ THUẬT &amp; ĐỐI CHIẾU HỢP ĐỒNG API (BUG-01)</a:t>
+              <a:t>TÓM TẮT KỸ THUẬT &amp; QUAN SÁT THỰC TẾ (BUG-01)</a:t>
             </a:r>
           </a:p>
           <a:p>
@@ -3847,18 +3852,18 @@
             <a:r>
               <a:rPr b="1" sz="1100">
                 <a:solidFill>
-                  <a:srgbClr val="89B4FA"/>
+                  <a:srgbClr val="61AFEF"/>
                 </a:solidFill>
               </a:rPr>
-              <a:t>• Endpoint &amp; Dữ liệu kích hoạt: </a:t>
+              <a:t>• Quan sát cốt lõi: </a:t>
             </a:r>
             <a:r>
               <a:rPr b="0" sz="1100">
                 <a:solidFill>
-                  <a:srgbClr val="CDD6F4"/>
+                  <a:srgbClr val="E6E6E6"/>
                 </a:solidFill>
               </a:rPr>
-              <a:t>POST /api/correspondents/ và POST /api/document_types/ với payload set_permissions.view = false (boolean thay vì object).</a:t>
+              <a:t>Gửi set_permissions.view dạng boolean dẫn đến HTTP 500 trên hai endpoint. Hệ thống cần từ chối đầu vào sai kiểu bằng phản hồi 4xx phù hợp.</a:t>
             </a:r>
           </a:p>
           <a:p>
@@ -3870,18 +3875,18 @@
             <a:r>
               <a:rPr b="1" sz="1100">
                 <a:solidFill>
-                  <a:srgbClr val="F38BA8"/>
+                  <a:srgbClr val="E06C75"/>
                 </a:solidFill>
               </a:rPr>
-              <a:t>• Thực tế hệ thống (Actual): </a:t>
+              <a:t>• Hiện tượng thực tế (Actual): </a:t>
             </a:r>
             <a:r>
               <a:rPr b="0" sz="1100">
                 <a:solidFill>
-                  <a:srgbClr val="CDD6F4"/>
+                  <a:srgbClr val="E6E6E6"/>
                 </a:solidFill>
               </a:rPr>
-              <a:t>HTTP 500 Internal Server Error dạng HTML; máy chủ Django gặp ngoại lệ chưa được xử lý (Unhandled Server Error).</a:t>
+              <a:t>HTTP 500 Internal Server Error (trang HTML Django); máy chủ phát sinh ngoại lệ chưa được xử lý (Unhandled Server Error) khi nhận boolean thay vì object.</a:t>
             </a:r>
           </a:p>
           <a:p>
@@ -3893,15 +3898,15 @@
             <a:r>
               <a:rPr b="1" sz="1100">
                 <a:solidFill>
-                  <a:srgbClr val="A6E3A1"/>
+                  <a:srgbClr val="98C379"/>
                 </a:solidFill>
               </a:rPr>
-              <a:t>• Kỳ vọng hợp đồng (Expected): </a:t>
+              <a:t>• Kỳ vọng đối chiếu (Expected): </a:t>
             </a:r>
             <a:r>
               <a:rPr b="0" sz="1100">
                 <a:solidFill>
-                  <a:srgbClr val="CDD6F4"/>
+                  <a:srgbClr val="E6E6E6"/>
                 </a:solidFill>
               </a:rPr>
               <a:t>HTTP 400 Bad Request; theo đặc tả OpenAPI, view phải là object chứa danh sách ID người dùng/nhóm ({users: [], groups: []}).</a:t>
@@ -3916,18 +3921,18 @@
             <a:r>
               <a:rPr b="1" sz="1100">
                 <a:solidFill>
-                  <a:srgbClr val="F9E2AF"/>
+                  <a:srgbClr val="E5C07B"/>
                 </a:solidFill>
               </a:rPr>
-              <a:t>• Trạng thái &amp; Kết luận: </a:t>
+              <a:t>• Phạm vi &amp; Kết luận kiểm thử: </a:t>
             </a:r>
             <a:r>
               <a:rPr b="0" sz="1100">
                 <a:solidFill>
-                  <a:srgbClr val="CDD6F4"/>
+                  <a:srgbClr val="E6E6E6"/>
                 </a:solidFill>
               </a:rPr>
-              <a:t>ĐÃ TÁI HIỆN THÀNH CÔNG 2 LẦN ĐỘC LẬP trên cả hai tài nguyên. Lỗi kiến trúc dùng chung ở tầng PermissionsMixin; chưa kết luận cụ thể nguyên nhân mã nguồn do thiếu traceback server nội bộ container.</a:t>
+              <a:t>Đã tái hiện độc lập trên cả hai endpoint: POST /api/correspondents/ và POST /api/document_types/. Không tự ý khẳng định lỗi ở tầng serializer hay ORM do chưa trích xuất traceback nội bộ container.</a:t>
             </a:r>
           </a:p>
         </p:txBody>
@@ -3946,7 +3951,7 @@
     <p:bg>
       <p:bgPr>
         <a:solidFill>
-          <a:srgbClr val="181825"/>
+          <a:srgbClr val="0C0C0C"/>
         </a:solidFill>
         <a:effectLst/>
       </p:bgPr>
@@ -3966,8 +3971,8 @@
         </p:nvSpPr>
         <p:spPr>
           <a:xfrm>
-            <a:off x="548640" y="320040"/>
-            <a:ext cx="8686800" cy="731520"/>
+            <a:off x="548640" y="292608"/>
+            <a:ext cx="8503920" cy="777240"/>
           </a:xfrm>
           <a:prstGeom prst="rect">
             <a:avLst/>
@@ -3981,21 +3986,21 @@
           <a:lstStyle/>
           <a:p>
             <a:pPr>
-              <a:defRPr sz="2200" b="1">
+              <a:defRPr sz="1900" b="1">
                 <a:solidFill>
-                  <a:srgbClr val="CDD6F4"/>
+                  <a:srgbClr val="E6E6E6"/>
                 </a:solidFill>
               </a:defRPr>
             </a:pPr>
             <a:r>
-              <a:t>BUG-03: Phản Hồi Tạo Mới Correspondent Không Khớp OpenAPI Schema</a:t>
+              <a:t>BUG-03: Phản Hồi Tạo Mới (201 Created) Thiếu Trường Bắt Buộc Theo Schema</a:t>
             </a:r>
           </a:p>
           <a:p>
             <a:pPr>
-              <a:defRPr sz="1200">
+              <a:defRPr sz="1150">
                 <a:solidFill>
-                  <a:srgbClr val="A6ADC8"/>
+                  <a:srgbClr val="969696"/>
                 </a:solidFill>
               </a:defRPr>
             </a:pPr>
@@ -4013,18 +4018,18 @@
         </p:nvSpPr>
         <p:spPr>
           <a:xfrm>
-            <a:off x="9601200" y="365760"/>
-            <a:ext cx="2011680" cy="411480"/>
+            <a:off x="9144000" y="365760"/>
+            <a:ext cx="2468880" cy="411480"/>
           </a:xfrm>
           <a:prstGeom prst="roundRect">
             <a:avLst/>
           </a:prstGeom>
           <a:solidFill>
-            <a:srgbClr val="F9E2AF"/>
+            <a:srgbClr val="E5C07B"/>
           </a:solidFill>
           <a:ln>
             <a:solidFill>
-              <a:srgbClr val="F9E2AF"/>
+              <a:srgbClr val="E5C07B"/>
             </a:solidFill>
           </a:ln>
         </p:spPr>
@@ -4047,14 +4052,14 @@
           <a:lstStyle/>
           <a:p>
             <a:pPr algn="ctr">
-              <a:defRPr sz="1200" b="1">
+              <a:defRPr sz="1100" b="1">
                 <a:solidFill>
-                  <a:srgbClr val="11111B"/>
+                  <a:srgbClr val="000000"/>
                 </a:solidFill>
               </a:defRPr>
             </a:pPr>
             <a:r>
-              <a:t>SAI LỆCH HỢP ĐỒNG (MEDIUM)</a:t>
+              <a:t>Severity đề xuất: Medium</a:t>
             </a:r>
           </a:p>
         </p:txBody>
@@ -4122,11 +4127,11 @@
             <a:avLst/>
           </a:prstGeom>
           <a:solidFill>
-            <a:srgbClr val="1E1E2E"/>
+            <a:srgbClr val="181818"/>
           </a:solidFill>
           <a:ln w="12700">
             <a:solidFill>
-              <a:srgbClr val="45475A"/>
+              <a:srgbClr val="333333"/>
             </a:solidFill>
           </a:ln>
         </p:spPr>
@@ -4151,7 +4156,7 @@
             <a:pPr algn="ctr">
               <a:defRPr sz="1300" b="1">
                 <a:solidFill>
-                  <a:srgbClr val="F9E2AF"/>
+                  <a:srgbClr val="E5C07B"/>
                 </a:solidFill>
               </a:defRPr>
             </a:pPr>
@@ -4168,18 +4173,18 @@
             <a:r>
               <a:rPr b="1" sz="1100">
                 <a:solidFill>
-                  <a:srgbClr val="89B4FA"/>
+                  <a:srgbClr val="61AFEF"/>
                 </a:solidFill>
               </a:rPr>
-              <a:t>• Thao tác &amp; Endpoint: </a:t>
+              <a:t>• Quan sát cốt lõi: </a:t>
             </a:r>
             <a:r>
               <a:rPr b="0" sz="1100">
                 <a:solidFill>
-                  <a:srgbClr val="CDD6F4"/>
+                  <a:srgbClr val="E6E6E6"/>
                 </a:solidFill>
               </a:rPr>
-              <a:t>POST /api/correspondents/ tạo mới bản ghi thành công với mã phản hồi HTTP 201 Created (ID tự sinh).</a:t>
+              <a:t>Response 201 của POST /api/correspondents/ thiếu các trường required đã đối chiếu trong OpenAPI, thể hiện sai lệch giữa phản hồi thực tế và hợp đồng API.</a:t>
             </a:r>
           </a:p>
           <a:p>
@@ -4191,7 +4196,7 @@
             <a:r>
               <a:rPr b="1" sz="1100">
                 <a:solidFill>
-                  <a:srgbClr val="F38BA8"/>
+                  <a:srgbClr val="E06C75"/>
                 </a:solidFill>
               </a:rPr>
               <a:t>• Trường bắt buộc bị thiếu đã xác minh: </a:t>
@@ -4199,10 +4204,10 @@
             <a:r>
               <a:rPr b="0" sz="1100">
                 <a:solidFill>
-                  <a:srgbClr val="CDD6F4"/>
+                  <a:srgbClr val="E6E6E6"/>
                 </a:solidFill>
               </a:rPr>
-              <a:t>Phản hồi 201 thực tế thiếu chính xác 3 trường required theo schema: document_count, last_correspondence, và permissions.</a:t>
+              <a:t>Đối chiếu trực tiếp schema Correspondent: phản hồi thực tế chỉ trả về 8 trường, thiếu chính xác 3 trường required: document_count, last_correspondence, permissions.</a:t>
             </a:r>
           </a:p>
           <a:p>
@@ -4214,18 +4219,18 @@
             <a:r>
               <a:rPr b="1" sz="1100">
                 <a:solidFill>
-                  <a:srgbClr val="A6E3A1"/>
+                  <a:srgbClr val="98C379"/>
                 </a:solidFill>
               </a:rPr>
-              <a:t>• Kiểm tra điều kiện full_perms: </a:t>
+              <a:t>• Giả thuyết kỹ thuật &amp; Hướng kiểm tra: </a:t>
             </a:r>
             <a:r>
               <a:rPr b="0" sz="1100">
                 <a:solidFill>
-                  <a:srgbClr val="CDD6F4"/>
+                  <a:srgbClr val="E6E6E6"/>
                 </a:solidFill>
               </a:rPr>
-              <a:t>Trường permissions chỉ trả về khi gọi GET với full_perms=true, nhưng schema OpenAPI lại đánh required vô điều kiện trong response 201 của POST.</a:t>
+              <a:t>Có thể do trường permissions phụ thuộc logic truy vấn GET có cờ full_perms=true, và các trường document_count, last_correspondence là trường annotate lúc lọc danh sách. Cần kiểm tra mã nguồn phiên bản 3.1.3 để xác minh trước khi đề xuất giải pháp tách serializer cho phản hồi 201.</a:t>
             </a:r>
           </a:p>
           <a:p>
@@ -4237,18 +4242,18 @@
             <a:r>
               <a:rPr b="1" sz="1100">
                 <a:solidFill>
-                  <a:srgbClr val="F9E2AF"/>
+                  <a:srgbClr val="E5C07B"/>
                 </a:solidFill>
               </a:rPr>
-              <a:t>• Phân loại sai lệch hợp đồng: </a:t>
+              <a:t>• Phạm vi ghi nhận hồ sơ: </a:t>
             </a:r>
             <a:r>
               <a:rPr b="0" sz="1100">
                 <a:solidFill>
-                  <a:srgbClr val="CDD6F4"/>
+                  <a:srgbClr val="E6E6E6"/>
                 </a:solidFill>
               </a:rPr>
-              <a:t>Sai lệch hợp đồng API (Schema Contract Violation) giữa drf-spectacular và response serializer; chưa quy kết lỗi ở backend hay tài liệu nếu chưa đủ bằng chứng. Hồ sơ TV3 chỉ khẳng định lỗi trên Correspondents.</a:t>
+              <a:t>Hồ sơ TV3 chỉ xác nhận lỗi này trên endpoint POST /api/correspondents/. Chưa mở rộng cho các tài nguyên khác nếu chưa kiểm thử độc lập.</a:t>
             </a:r>
           </a:p>
         </p:txBody>

</xml_diff>

<commit_message>
docs(TV3): integrate real user screenshots TV3_REAL_ into bug evidence slides with objective observations
</commit_message>
<xml_diff>
--- a/docs/slides/TV3_BUG_EVIDENCE_303.pptx
+++ b/docs/slides/TV3_BUG_EVIDENCE_303.pptx
@@ -513,7 +513,7 @@
           </a:p>
           <a:p>
             <a:r>
-              <a:t>- Bằng chứng thực thi: docs/evidence/TV3_BUG01_correspondents_500.png và docs/evidence/TV3_BUG01_document_types_500.png.</a:t>
+              <a:t>- Bằng chứng thực tế: Hai ảnh chụp màn hình thực tế tại docs/evidence/TV3_REAL_BUG01_correspondents_500.png và docs/evidence/TV3_REAL_BUG01_document_types_500.png.</a:t>
             </a:r>
           </a:p>
           <a:p>
@@ -608,22 +608,22 @@
           </a:p>
           <a:p>
             <a:r>
-              <a:t>- Bằng chứng thực thi: docs/evidence/TV3_BUG03_response_201.png và đối chiếu hợp đồng tại docs/evidence/TV3_BUG03_schema_required.png (trích xuất từ docs/openapi_TV3.json, SHA256: 888b0f89...).</a:t>
-            </a:r>
-          </a:p>
-          <a:p>
-            <a:r>
-              <a:t>- Quan sát cốt lõi: Response 201 của POST /api/correspondents/ thiếu các trường required đã đối chiếu trong OpenAPI, thể hiện sai lệch giữa phản hồi thực tế và hợp đồng API.</a:t>
-            </a:r>
-          </a:p>
-          <a:p>
-            <a:r>
-              <a:t>- Xác minh cụ thể: Cả 3 trường document_count, last_correspondence, permissions đều được schema đánh dấu là required nhưng vắng mặt hoàn toàn trong response 201.</a:t>
-            </a:r>
-          </a:p>
-          <a:p>
-            <a:r>
-              <a:t>- Đánh giá mức độ nghiêm trọng: Severity đề xuất là Medium vì chức năng tạo mới đối tượng trên cơ sở dữ liệu vẫn thành công, nhưng client tự động sinh từ OpenAPI schema có thể bị crash khi parse thiếu trường bắt buộc.</a:t>
+              <a:t>- Bằng chứng thực tế: Ảnh chụp màn hình thực tế (docs/evidence/TV3_REAL_BUG03_response_201.png) và Trích xuất OpenAPI schema (docs/evidence/TV3_BUG03_schema_required.png, SHA256: 888b0f89...).</a:t>
+            </a:r>
+          </a:p>
+          <a:p>
+            <a:r>
+              <a:t>- Quan sát cốt lõi: Khi gửi request POST /api/correspondents/, máy chủ trả HTTP 201 Created nhưng response body thiếu 3 trường required đã đối chiếu trong OpenAPI (document_count, last_correspondence, permissions), thể hiện sai lệch giữa phản hồi thực tế và hợp đồng API.</a:t>
+            </a:r>
+          </a:p>
+          <a:p>
+            <a:r>
+              <a:t>- Lưu ý bảo vệ đồ án: Chỉ khẳng định kết quả quan sát được từ phản hồi HTTP 201 của máy chủ; không khẳng định đã xác minh lưu vào database vì chưa kiểm tra lại bản ghi bằng phương thức GET.</a:t>
+            </a:r>
+          </a:p>
+          <a:p>
+            <a:r>
+              <a:t>- Đánh giá mức độ nghiêm trọng: Severity đề xuất là Medium (sai lệch hợp đồng API, client tự động sinh có thể gặp lỗi deserialize).</a:t>
             </a:r>
           </a:p>
           <a:p>
@@ -3650,7 +3650,7 @@
         </p:nvSpPr>
         <p:spPr>
           <a:xfrm>
-            <a:off x="548640" y="292608"/>
+            <a:off x="548640" y="256032"/>
             <a:ext cx="8503920" cy="777240"/>
           </a:xfrm>
           <a:prstGeom prst="rect">
@@ -3697,8 +3697,8 @@
         </p:nvSpPr>
         <p:spPr>
           <a:xfrm>
-            <a:off x="9144000" y="365760"/>
-            <a:ext cx="2468880" cy="411480"/>
+            <a:off x="9144000" y="320040"/>
+            <a:ext cx="2468880" cy="384048"/>
           </a:xfrm>
           <a:prstGeom prst="roundRect">
             <a:avLst/>
@@ -3743,74 +3743,26 @@
           </a:p>
         </p:txBody>
       </p:sp>
-      <p:pic>
-        <p:nvPicPr>
-          <p:cNvPr id="4" name="Picture 3" descr="TV3_BUG01_correspondents_500.png"/>
-          <p:cNvPicPr>
-            <a:picLocks noChangeAspect="1"/>
-          </p:cNvPicPr>
+      <p:sp>
+        <p:nvSpPr>
+          <p:cNvPr id="4" name="Rectangle 3"/>
+          <p:cNvSpPr/>
           <p:nvPr/>
-        </p:nvPicPr>
-        <p:blipFill>
-          <a:blip r:embed="rId2"/>
-          <a:stretch>
-            <a:fillRect/>
-          </a:stretch>
-        </p:blipFill>
+        </p:nvSpPr>
         <p:spPr>
           <a:xfrm>
-            <a:off x="548640" y="1188720"/>
-            <a:ext cx="5394960" cy="3035808"/>
+            <a:off x="548640" y="1143000"/>
+            <a:ext cx="5440680" cy="2971800"/>
           </a:xfrm>
           <a:prstGeom prst="rect">
             <a:avLst/>
           </a:prstGeom>
-        </p:spPr>
-      </p:pic>
-      <p:pic>
-        <p:nvPicPr>
-          <p:cNvPr id="5" name="Picture 4" descr="TV3_BUG01_document_types_500.png"/>
-          <p:cNvPicPr>
-            <a:picLocks noChangeAspect="1"/>
-          </p:cNvPicPr>
-          <p:nvPr/>
-        </p:nvPicPr>
-        <p:blipFill>
-          <a:blip r:embed="rId3"/>
-          <a:stretch>
-            <a:fillRect/>
-          </a:stretch>
-        </p:blipFill>
-        <p:spPr>
-          <a:xfrm>
-            <a:off x="6217920" y="1188720"/>
-            <a:ext cx="5394960" cy="3035808"/>
-          </a:xfrm>
-          <a:prstGeom prst="rect">
-            <a:avLst/>
-          </a:prstGeom>
-        </p:spPr>
-      </p:pic>
-      <p:sp>
-        <p:nvSpPr>
-          <p:cNvPr id="6" name="Rounded Rectangle 5"/>
-          <p:cNvSpPr/>
-          <p:nvPr/>
-        </p:nvSpPr>
-        <p:spPr>
-          <a:xfrm>
-            <a:off x="548640" y="4343400"/>
-            <a:ext cx="11064240" cy="2148840"/>
-          </a:xfrm>
-          <a:prstGeom prst="roundRect">
-            <a:avLst/>
-          </a:prstGeom>
           <a:solidFill>
-            <a:srgbClr val="181818"/>
+            <a:srgbClr val="141414"/>
           </a:solidFill>
           <a:ln w="12700">
             <a:solidFill>
-              <a:srgbClr val="333333"/>
+              <a:srgbClr val="2D2D2D"/>
             </a:solidFill>
           </a:ln>
         </p:spPr>
@@ -3829,6 +3781,252 @@
           </a:fontRef>
         </p:style>
         <p:txBody>
+          <a:bodyPr rtlCol="0" anchor="ctr"/>
+          <a:lstStyle/>
+          <a:p>
+            <a:pPr algn="ctr"/>
+          </a:p>
+        </p:txBody>
+      </p:sp>
+      <p:sp>
+        <p:nvSpPr>
+          <p:cNvPr id="5" name="Rectangle 4"/>
+          <p:cNvSpPr/>
+          <p:nvPr/>
+        </p:nvSpPr>
+        <p:spPr>
+          <a:xfrm>
+            <a:off x="548640" y="1143000"/>
+            <a:ext cx="5440680" cy="292608"/>
+          </a:xfrm>
+          <a:prstGeom prst="rect">
+            <a:avLst/>
+          </a:prstGeom>
+          <a:solidFill>
+            <a:srgbClr val="1E1E1E"/>
+          </a:solidFill>
+          <a:ln w="12700">
+            <a:solidFill>
+              <a:srgbClr val="2D2D2D"/>
+            </a:solidFill>
+          </a:ln>
+        </p:spPr>
+        <p:style>
+          <a:lnRef idx="1">
+            <a:schemeClr val="accent1"/>
+          </a:lnRef>
+          <a:fillRef idx="3">
+            <a:schemeClr val="accent1"/>
+          </a:fillRef>
+          <a:effectRef idx="2">
+            <a:schemeClr val="accent1"/>
+          </a:effectRef>
+          <a:fontRef idx="minor">
+            <a:schemeClr val="lt1"/>
+          </a:fontRef>
+        </p:style>
+        <p:txBody>
+          <a:bodyPr rtlCol="0" anchor="ctr" lIns="109728" tIns="36576" bIns="0" rIns="0"/>
+          <a:lstStyle/>
+          <a:p>
+            <a:pPr algn="ctr">
+              <a:defRPr sz="950" b="1">
+                <a:solidFill>
+                  <a:srgbClr val="E5C07B"/>
+                </a:solidFill>
+              </a:defRPr>
+            </a:pPr>
+            <a:r>
+              <a:t>Ảnh chụp màn hình thực tế: POST /api/correspondents/ (HTTP 500 Server Error)</a:t>
+            </a:r>
+          </a:p>
+        </p:txBody>
+      </p:sp>
+      <p:pic>
+        <p:nvPicPr>
+          <p:cNvPr id="6" name="Picture 5" descr="TV3_REAL_BUG01_correspondents_500.png"/>
+          <p:cNvPicPr>
+            <a:picLocks noChangeAspect="1"/>
+          </p:cNvPicPr>
+          <p:nvPr/>
+        </p:nvPicPr>
+        <p:blipFill>
+          <a:blip r:embed="rId2"/>
+          <a:stretch>
+            <a:fillRect/>
+          </a:stretch>
+        </p:blipFill>
+        <p:spPr>
+          <a:xfrm>
+            <a:off x="621792" y="1934804"/>
+            <a:ext cx="5294376" cy="1680798"/>
+          </a:xfrm>
+          <a:prstGeom prst="rect">
+            <a:avLst/>
+          </a:prstGeom>
+        </p:spPr>
+      </p:pic>
+      <p:sp>
+        <p:nvSpPr>
+          <p:cNvPr id="7" name="Rectangle 6"/>
+          <p:cNvSpPr/>
+          <p:nvPr/>
+        </p:nvSpPr>
+        <p:spPr>
+          <a:xfrm>
+            <a:off x="6172200" y="1143000"/>
+            <a:ext cx="5440680" cy="2971800"/>
+          </a:xfrm>
+          <a:prstGeom prst="rect">
+            <a:avLst/>
+          </a:prstGeom>
+          <a:solidFill>
+            <a:srgbClr val="141414"/>
+          </a:solidFill>
+          <a:ln w="12700">
+            <a:solidFill>
+              <a:srgbClr val="2D2D2D"/>
+            </a:solidFill>
+          </a:ln>
+        </p:spPr>
+        <p:style>
+          <a:lnRef idx="1">
+            <a:schemeClr val="accent1"/>
+          </a:lnRef>
+          <a:fillRef idx="3">
+            <a:schemeClr val="accent1"/>
+          </a:fillRef>
+          <a:effectRef idx="2">
+            <a:schemeClr val="accent1"/>
+          </a:effectRef>
+          <a:fontRef idx="minor">
+            <a:schemeClr val="lt1"/>
+          </a:fontRef>
+        </p:style>
+        <p:txBody>
+          <a:bodyPr rtlCol="0" anchor="ctr"/>
+          <a:lstStyle/>
+          <a:p>
+            <a:pPr algn="ctr"/>
+          </a:p>
+        </p:txBody>
+      </p:sp>
+      <p:sp>
+        <p:nvSpPr>
+          <p:cNvPr id="8" name="Rectangle 7"/>
+          <p:cNvSpPr/>
+          <p:nvPr/>
+        </p:nvSpPr>
+        <p:spPr>
+          <a:xfrm>
+            <a:off x="6172200" y="1143000"/>
+            <a:ext cx="5440680" cy="292608"/>
+          </a:xfrm>
+          <a:prstGeom prst="rect">
+            <a:avLst/>
+          </a:prstGeom>
+          <a:solidFill>
+            <a:srgbClr val="1E1E1E"/>
+          </a:solidFill>
+          <a:ln w="12700">
+            <a:solidFill>
+              <a:srgbClr val="2D2D2D"/>
+            </a:solidFill>
+          </a:ln>
+        </p:spPr>
+        <p:style>
+          <a:lnRef idx="1">
+            <a:schemeClr val="accent1"/>
+          </a:lnRef>
+          <a:fillRef idx="3">
+            <a:schemeClr val="accent1"/>
+          </a:fillRef>
+          <a:effectRef idx="2">
+            <a:schemeClr val="accent1"/>
+          </a:effectRef>
+          <a:fontRef idx="minor">
+            <a:schemeClr val="lt1"/>
+          </a:fontRef>
+        </p:style>
+        <p:txBody>
+          <a:bodyPr rtlCol="0" anchor="ctr" lIns="109728" tIns="36576" bIns="0" rIns="0"/>
+          <a:lstStyle/>
+          <a:p>
+            <a:pPr algn="ctr">
+              <a:defRPr sz="950" b="1">
+                <a:solidFill>
+                  <a:srgbClr val="E5C07B"/>
+                </a:solidFill>
+              </a:defRPr>
+            </a:pPr>
+            <a:r>
+              <a:t>Ảnh chụp màn hình thực tế: POST /api/document_types/ (HTTP 500 Server Error)</a:t>
+            </a:r>
+          </a:p>
+        </p:txBody>
+      </p:sp>
+      <p:pic>
+        <p:nvPicPr>
+          <p:cNvPr id="9" name="Picture 8" descr="TV3_REAL_BUG01_document_types_500.png"/>
+          <p:cNvPicPr>
+            <a:picLocks noChangeAspect="1"/>
+          </p:cNvPicPr>
+          <p:nvPr/>
+        </p:nvPicPr>
+        <p:blipFill>
+          <a:blip r:embed="rId3"/>
+          <a:stretch>
+            <a:fillRect/>
+          </a:stretch>
+        </p:blipFill>
+        <p:spPr>
+          <a:xfrm>
+            <a:off x="6245352" y="1968876"/>
+            <a:ext cx="5294376" cy="1612654"/>
+          </a:xfrm>
+          <a:prstGeom prst="rect">
+            <a:avLst/>
+          </a:prstGeom>
+        </p:spPr>
+      </p:pic>
+      <p:sp>
+        <p:nvSpPr>
+          <p:cNvPr id="10" name="Rounded Rectangle 9"/>
+          <p:cNvSpPr/>
+          <p:nvPr/>
+        </p:nvSpPr>
+        <p:spPr>
+          <a:xfrm>
+            <a:off x="548640" y="4251960"/>
+            <a:ext cx="11064240" cy="2240280"/>
+          </a:xfrm>
+          <a:prstGeom prst="roundRect">
+            <a:avLst/>
+          </a:prstGeom>
+          <a:solidFill>
+            <a:srgbClr val="141414"/>
+          </a:solidFill>
+          <a:ln w="12700">
+            <a:solidFill>
+              <a:srgbClr val="2D2D2D"/>
+            </a:solidFill>
+          </a:ln>
+        </p:spPr>
+        <p:style>
+          <a:lnRef idx="1">
+            <a:schemeClr val="accent1"/>
+          </a:lnRef>
+          <a:fillRef idx="3">
+            <a:schemeClr val="accent1"/>
+          </a:fillRef>
+          <a:effectRef idx="2">
+            <a:schemeClr val="accent1"/>
+          </a:effectRef>
+          <a:fontRef idx="minor">
+            <a:schemeClr val="lt1"/>
+          </a:fontRef>
+        </p:style>
+        <p:txBody>
           <a:bodyPr rtlCol="0" anchor="ctr" wrap="square" lIns="228600" rIns="228600" tIns="164592" bIns="137160"/>
           <a:lstStyle/>
           <a:p>
@@ -3850,7 +4048,7 @@
               </a:spcAft>
             </a:pPr>
             <a:r>
-              <a:rPr b="1" sz="1100">
+              <a:rPr b="1" sz="1050">
                 <a:solidFill>
                   <a:srgbClr val="61AFEF"/>
                 </a:solidFill>
@@ -3858,7 +4056,7 @@
               <a:t>• Quan sát cốt lõi: </a:t>
             </a:r>
             <a:r>
-              <a:rPr b="0" sz="1100">
+              <a:rPr b="0" sz="1050">
                 <a:solidFill>
                   <a:srgbClr val="E6E6E6"/>
                 </a:solidFill>
@@ -3873,7 +4071,7 @@
               </a:spcAft>
             </a:pPr>
             <a:r>
-              <a:rPr b="1" sz="1100">
+              <a:rPr b="1" sz="1050">
                 <a:solidFill>
                   <a:srgbClr val="E06C75"/>
                 </a:solidFill>
@@ -3881,7 +4079,7 @@
               <a:t>• Hiện tượng thực tế (Actual): </a:t>
             </a:r>
             <a:r>
-              <a:rPr b="0" sz="1100">
+              <a:rPr b="0" sz="1050">
                 <a:solidFill>
                   <a:srgbClr val="E6E6E6"/>
                 </a:solidFill>
@@ -3896,7 +4094,7 @@
               </a:spcAft>
             </a:pPr>
             <a:r>
-              <a:rPr b="1" sz="1100">
+              <a:rPr b="1" sz="1050">
                 <a:solidFill>
                   <a:srgbClr val="98C379"/>
                 </a:solidFill>
@@ -3904,7 +4102,7 @@
               <a:t>• Kỳ vọng đối chiếu (Expected): </a:t>
             </a:r>
             <a:r>
-              <a:rPr b="0" sz="1100">
+              <a:rPr b="0" sz="1050">
                 <a:solidFill>
                   <a:srgbClr val="E6E6E6"/>
                 </a:solidFill>
@@ -3919,7 +4117,7 @@
               </a:spcAft>
             </a:pPr>
             <a:r>
-              <a:rPr b="1" sz="1100">
+              <a:rPr b="1" sz="1050">
                 <a:solidFill>
                   <a:srgbClr val="E5C07B"/>
                 </a:solidFill>
@@ -3927,7 +4125,7 @@
               <a:t>• Phạm vi &amp; Kết luận kiểm thử: </a:t>
             </a:r>
             <a:r>
-              <a:rPr b="0" sz="1100">
+              <a:rPr b="0" sz="1050">
                 <a:solidFill>
                   <a:srgbClr val="E6E6E6"/>
                 </a:solidFill>
@@ -3971,7 +4169,7 @@
         </p:nvSpPr>
         <p:spPr>
           <a:xfrm>
-            <a:off x="548640" y="292608"/>
+            <a:off x="548640" y="256032"/>
             <a:ext cx="8503920" cy="777240"/>
           </a:xfrm>
           <a:prstGeom prst="rect">
@@ -4018,8 +4216,8 @@
         </p:nvSpPr>
         <p:spPr>
           <a:xfrm>
-            <a:off x="9144000" y="365760"/>
-            <a:ext cx="2468880" cy="411480"/>
+            <a:off x="9144000" y="320040"/>
+            <a:ext cx="2468880" cy="384048"/>
           </a:xfrm>
           <a:prstGeom prst="roundRect">
             <a:avLst/>
@@ -4064,74 +4262,26 @@
           </a:p>
         </p:txBody>
       </p:sp>
-      <p:pic>
-        <p:nvPicPr>
-          <p:cNvPr id="4" name="Picture 3" descr="TV3_BUG03_response_201.png"/>
-          <p:cNvPicPr>
-            <a:picLocks noChangeAspect="1"/>
-          </p:cNvPicPr>
+      <p:sp>
+        <p:nvSpPr>
+          <p:cNvPr id="4" name="Rectangle 3"/>
+          <p:cNvSpPr/>
           <p:nvPr/>
-        </p:nvPicPr>
-        <p:blipFill>
-          <a:blip r:embed="rId2"/>
-          <a:stretch>
-            <a:fillRect/>
-          </a:stretch>
-        </p:blipFill>
+        </p:nvSpPr>
         <p:spPr>
           <a:xfrm>
-            <a:off x="548640" y="1188720"/>
-            <a:ext cx="5394960" cy="3035808"/>
+            <a:off x="548640" y="1143000"/>
+            <a:ext cx="5440680" cy="2971800"/>
           </a:xfrm>
           <a:prstGeom prst="rect">
             <a:avLst/>
           </a:prstGeom>
-        </p:spPr>
-      </p:pic>
-      <p:pic>
-        <p:nvPicPr>
-          <p:cNvPr id="5" name="Picture 4" descr="TV3_BUG03_schema_required.png"/>
-          <p:cNvPicPr>
-            <a:picLocks noChangeAspect="1"/>
-          </p:cNvPicPr>
-          <p:nvPr/>
-        </p:nvPicPr>
-        <p:blipFill>
-          <a:blip r:embed="rId3"/>
-          <a:stretch>
-            <a:fillRect/>
-          </a:stretch>
-        </p:blipFill>
-        <p:spPr>
-          <a:xfrm>
-            <a:off x="6217920" y="1188720"/>
-            <a:ext cx="5394960" cy="3035808"/>
-          </a:xfrm>
-          <a:prstGeom prst="rect">
-            <a:avLst/>
-          </a:prstGeom>
-        </p:spPr>
-      </p:pic>
-      <p:sp>
-        <p:nvSpPr>
-          <p:cNvPr id="6" name="Rounded Rectangle 5"/>
-          <p:cNvSpPr/>
-          <p:nvPr/>
-        </p:nvSpPr>
-        <p:spPr>
-          <a:xfrm>
-            <a:off x="548640" y="4343400"/>
-            <a:ext cx="11064240" cy="2148840"/>
-          </a:xfrm>
-          <a:prstGeom prst="roundRect">
-            <a:avLst/>
-          </a:prstGeom>
           <a:solidFill>
-            <a:srgbClr val="181818"/>
+            <a:srgbClr val="141414"/>
           </a:solidFill>
           <a:ln w="12700">
             <a:solidFill>
-              <a:srgbClr val="333333"/>
+              <a:srgbClr val="2D2D2D"/>
             </a:solidFill>
           </a:ln>
         </p:spPr>
@@ -4150,6 +4300,252 @@
           </a:fontRef>
         </p:style>
         <p:txBody>
+          <a:bodyPr rtlCol="0" anchor="ctr"/>
+          <a:lstStyle/>
+          <a:p>
+            <a:pPr algn="ctr"/>
+          </a:p>
+        </p:txBody>
+      </p:sp>
+      <p:sp>
+        <p:nvSpPr>
+          <p:cNvPr id="5" name="Rectangle 4"/>
+          <p:cNvSpPr/>
+          <p:nvPr/>
+        </p:nvSpPr>
+        <p:spPr>
+          <a:xfrm>
+            <a:off x="548640" y="1143000"/>
+            <a:ext cx="5440680" cy="292608"/>
+          </a:xfrm>
+          <a:prstGeom prst="rect">
+            <a:avLst/>
+          </a:prstGeom>
+          <a:solidFill>
+            <a:srgbClr val="1E1E1E"/>
+          </a:solidFill>
+          <a:ln w="12700">
+            <a:solidFill>
+              <a:srgbClr val="2D2D2D"/>
+            </a:solidFill>
+          </a:ln>
+        </p:spPr>
+        <p:style>
+          <a:lnRef idx="1">
+            <a:schemeClr val="accent1"/>
+          </a:lnRef>
+          <a:fillRef idx="3">
+            <a:schemeClr val="accent1"/>
+          </a:fillRef>
+          <a:effectRef idx="2">
+            <a:schemeClr val="accent1"/>
+          </a:effectRef>
+          <a:fontRef idx="minor">
+            <a:schemeClr val="lt1"/>
+          </a:fontRef>
+        </p:style>
+        <p:txBody>
+          <a:bodyPr rtlCol="0" anchor="ctr" lIns="109728" tIns="36576" bIns="0" rIns="0"/>
+          <a:lstStyle/>
+          <a:p>
+            <a:pPr algn="ctr">
+              <a:defRPr sz="950" b="1">
+                <a:solidFill>
+                  <a:srgbClr val="E5C07B"/>
+                </a:solidFill>
+              </a:defRPr>
+            </a:pPr>
+            <a:r>
+              <a:t>Ảnh chụp màn hình thực tế: POST /api/correspondents/ (Máy chủ trả HTTP 201)</a:t>
+            </a:r>
+          </a:p>
+        </p:txBody>
+      </p:sp>
+      <p:pic>
+        <p:nvPicPr>
+          <p:cNvPr id="6" name="Picture 5" descr="TV3_REAL_BUG03_response_201.png"/>
+          <p:cNvPicPr>
+            <a:picLocks noChangeAspect="1"/>
+          </p:cNvPicPr>
+          <p:nvPr/>
+        </p:nvPicPr>
+        <p:blipFill>
+          <a:blip r:embed="rId2"/>
+          <a:stretch>
+            <a:fillRect/>
+          </a:stretch>
+        </p:blipFill>
+        <p:spPr>
+          <a:xfrm>
+            <a:off x="621792" y="2129615"/>
+            <a:ext cx="5294376" cy="1291176"/>
+          </a:xfrm>
+          <a:prstGeom prst="rect">
+            <a:avLst/>
+          </a:prstGeom>
+        </p:spPr>
+      </p:pic>
+      <p:sp>
+        <p:nvSpPr>
+          <p:cNvPr id="7" name="Rectangle 6"/>
+          <p:cNvSpPr/>
+          <p:nvPr/>
+        </p:nvSpPr>
+        <p:spPr>
+          <a:xfrm>
+            <a:off x="6172200" y="1143000"/>
+            <a:ext cx="5440680" cy="2971800"/>
+          </a:xfrm>
+          <a:prstGeom prst="rect">
+            <a:avLst/>
+          </a:prstGeom>
+          <a:solidFill>
+            <a:srgbClr val="141414"/>
+          </a:solidFill>
+          <a:ln w="12700">
+            <a:solidFill>
+              <a:srgbClr val="2D2D2D"/>
+            </a:solidFill>
+          </a:ln>
+        </p:spPr>
+        <p:style>
+          <a:lnRef idx="1">
+            <a:schemeClr val="accent1"/>
+          </a:lnRef>
+          <a:fillRef idx="3">
+            <a:schemeClr val="accent1"/>
+          </a:fillRef>
+          <a:effectRef idx="2">
+            <a:schemeClr val="accent1"/>
+          </a:effectRef>
+          <a:fontRef idx="minor">
+            <a:schemeClr val="lt1"/>
+          </a:fontRef>
+        </p:style>
+        <p:txBody>
+          <a:bodyPr rtlCol="0" anchor="ctr"/>
+          <a:lstStyle/>
+          <a:p>
+            <a:pPr algn="ctr"/>
+          </a:p>
+        </p:txBody>
+      </p:sp>
+      <p:sp>
+        <p:nvSpPr>
+          <p:cNvPr id="8" name="Rectangle 7"/>
+          <p:cNvSpPr/>
+          <p:nvPr/>
+        </p:nvSpPr>
+        <p:spPr>
+          <a:xfrm>
+            <a:off x="6172200" y="1143000"/>
+            <a:ext cx="5440680" cy="292608"/>
+          </a:xfrm>
+          <a:prstGeom prst="rect">
+            <a:avLst/>
+          </a:prstGeom>
+          <a:solidFill>
+            <a:srgbClr val="1E1E1E"/>
+          </a:solidFill>
+          <a:ln w="12700">
+            <a:solidFill>
+              <a:srgbClr val="2D2D2D"/>
+            </a:solidFill>
+          </a:ln>
+        </p:spPr>
+        <p:style>
+          <a:lnRef idx="1">
+            <a:schemeClr val="accent1"/>
+          </a:lnRef>
+          <a:fillRef idx="3">
+            <a:schemeClr val="accent1"/>
+          </a:fillRef>
+          <a:effectRef idx="2">
+            <a:schemeClr val="accent1"/>
+          </a:effectRef>
+          <a:fontRef idx="minor">
+            <a:schemeClr val="lt1"/>
+          </a:fontRef>
+        </p:style>
+        <p:txBody>
+          <a:bodyPr rtlCol="0" anchor="ctr" lIns="109728" tIns="36576" bIns="0" rIns="0"/>
+          <a:lstStyle/>
+          <a:p>
+            <a:pPr algn="ctr">
+              <a:defRPr sz="950" b="1">
+                <a:solidFill>
+                  <a:srgbClr val="E5C07B"/>
+                </a:solidFill>
+              </a:defRPr>
+            </a:pPr>
+            <a:r>
+              <a:t>Trích xuất OpenAPI schema: Cấu trúc response 201 (#/components/schemas/Correspondent)</a:t>
+            </a:r>
+          </a:p>
+        </p:txBody>
+      </p:sp>
+      <p:pic>
+        <p:nvPicPr>
+          <p:cNvPr id="9" name="Picture 8" descr="TV3_BUG03_schema_required.png"/>
+          <p:cNvPicPr>
+            <a:picLocks noChangeAspect="1"/>
+          </p:cNvPicPr>
+          <p:nvPr/>
+        </p:nvPicPr>
+        <p:blipFill>
+          <a:blip r:embed="rId3"/>
+          <a:stretch>
+            <a:fillRect/>
+          </a:stretch>
+        </p:blipFill>
+        <p:spPr>
+          <a:xfrm>
+            <a:off x="6598375" y="1490472"/>
+            <a:ext cx="4588328" cy="2569464"/>
+          </a:xfrm>
+          <a:prstGeom prst="rect">
+            <a:avLst/>
+          </a:prstGeom>
+        </p:spPr>
+      </p:pic>
+      <p:sp>
+        <p:nvSpPr>
+          <p:cNvPr id="10" name="Rounded Rectangle 9"/>
+          <p:cNvSpPr/>
+          <p:nvPr/>
+        </p:nvSpPr>
+        <p:spPr>
+          <a:xfrm>
+            <a:off x="548640" y="4251960"/>
+            <a:ext cx="11064240" cy="2240280"/>
+          </a:xfrm>
+          <a:prstGeom prst="roundRect">
+            <a:avLst/>
+          </a:prstGeom>
+          <a:solidFill>
+            <a:srgbClr val="141414"/>
+          </a:solidFill>
+          <a:ln w="12700">
+            <a:solidFill>
+              <a:srgbClr val="2D2D2D"/>
+            </a:solidFill>
+          </a:ln>
+        </p:spPr>
+        <p:style>
+          <a:lnRef idx="1">
+            <a:schemeClr val="accent1"/>
+          </a:lnRef>
+          <a:fillRef idx="3">
+            <a:schemeClr val="accent1"/>
+          </a:fillRef>
+          <a:effectRef idx="2">
+            <a:schemeClr val="accent1"/>
+          </a:effectRef>
+          <a:fontRef idx="minor">
+            <a:schemeClr val="lt1"/>
+          </a:fontRef>
+        </p:style>
+        <p:txBody>
           <a:bodyPr rtlCol="0" anchor="ctr" wrap="square" lIns="228600" rIns="228600" tIns="164592" bIns="137160"/>
           <a:lstStyle/>
           <a:p>
@@ -4167,11 +4563,11 @@
           <a:p>
             <a:pPr>
               <a:spcAft>
-                <a:spcPts val="400"/>
+                <a:spcPts val="300"/>
               </a:spcAft>
             </a:pPr>
             <a:r>
-              <a:rPr b="1" sz="1100">
+              <a:rPr b="1" sz="1050">
                 <a:solidFill>
                   <a:srgbClr val="61AFEF"/>
                 </a:solidFill>
@@ -4179,7 +4575,7 @@
               <a:t>• Quan sát cốt lõi: </a:t>
             </a:r>
             <a:r>
-              <a:rPr b="0" sz="1100">
+              <a:rPr b="0" sz="1050">
                 <a:solidFill>
                   <a:srgbClr val="E6E6E6"/>
                 </a:solidFill>
@@ -4190,11 +4586,11 @@
           <a:p>
             <a:pPr>
               <a:spcAft>
-                <a:spcPts val="400"/>
+                <a:spcPts val="300"/>
               </a:spcAft>
             </a:pPr>
             <a:r>
-              <a:rPr b="1" sz="1100">
+              <a:rPr b="1" sz="1050">
                 <a:solidFill>
                   <a:srgbClr val="E06C75"/>
                 </a:solidFill>
@@ -4202,7 +4598,7 @@
               <a:t>• Trường bắt buộc bị thiếu đã xác minh: </a:t>
             </a:r>
             <a:r>
-              <a:rPr b="0" sz="1100">
+              <a:rPr b="0" sz="1050">
                 <a:solidFill>
                   <a:srgbClr val="E6E6E6"/>
                 </a:solidFill>
@@ -4213,19 +4609,42 @@
           <a:p>
             <a:pPr>
               <a:spcAft>
-                <a:spcPts val="400"/>
+                <a:spcPts val="300"/>
               </a:spcAft>
             </a:pPr>
             <a:r>
-              <a:rPr b="1" sz="1100">
+              <a:rPr b="1" sz="1050">
                 <a:solidFill>
                   <a:srgbClr val="98C379"/>
                 </a:solidFill>
               </a:rPr>
+              <a:t>• Hiện tượng quan sát (Actual): </a:t>
+            </a:r>
+            <a:r>
+              <a:rPr b="0" sz="1050">
+                <a:solidFill>
+                  <a:srgbClr val="E6E6E6"/>
+                </a:solidFill>
+              </a:rPr>
+              <a:t>Khi gửi POST tạo mới, máy chủ trả HTTP 201 Created nhưng payload thiếu 3 trường required. Do chưa kiểm tra lại bản ghi bằng phương thức GET, hồ sơ chỉ ghi nhận kết quả quan sát trực tiếp từ phản hồi HTTP 201 của máy chủ (không khẳng định đã xác minh lưu database).</a:t>
+            </a:r>
+          </a:p>
+          <a:p>
+            <a:pPr>
+              <a:spcAft>
+                <a:spcPts val="300"/>
+              </a:spcAft>
+            </a:pPr>
+            <a:r>
+              <a:rPr b="1" sz="1050">
+                <a:solidFill>
+                  <a:srgbClr val="E5C07B"/>
+                </a:solidFill>
+              </a:rPr>
               <a:t>• Giả thuyết kỹ thuật &amp; Hướng kiểm tra: </a:t>
             </a:r>
             <a:r>
-              <a:rPr b="0" sz="1100">
+              <a:rPr b="0" sz="1050">
                 <a:solidFill>
                   <a:srgbClr val="E6E6E6"/>
                 </a:solidFill>
@@ -4236,19 +4655,19 @@
           <a:p>
             <a:pPr>
               <a:spcAft>
-                <a:spcPts val="400"/>
+                <a:spcPts val="300"/>
               </a:spcAft>
             </a:pPr>
             <a:r>
-              <a:rPr b="1" sz="1100">
+              <a:rPr b="1" sz="1050">
                 <a:solidFill>
-                  <a:srgbClr val="E5C07B"/>
+                  <a:srgbClr val="969696"/>
                 </a:solidFill>
               </a:rPr>
               <a:t>• Phạm vi ghi nhận hồ sơ: </a:t>
             </a:r>
             <a:r>
-              <a:rPr b="0" sz="1100">
+              <a:rPr b="0" sz="1050">
                 <a:solidFill>
                   <a:srgbClr val="E6E6E6"/>
                 </a:solidFill>

</xml_diff>